<commit_message>
updated manuscript and plots
</commit_message>
<xml_diff>
--- a/figs/boxplot_of_betas_and_table.pptx
+++ b/figs/boxplot_of_betas_and_table.pptx
@@ -260,7 +260,7 @@
           <a:p>
             <a:fld id="{36763DCB-CE5A-6A42-9D77-F16639D72981}" type="datetimeFigureOut">
               <a:rPr lang="en-US" smtClean="0"/>
-              <a:t>5/1/25</a:t>
+              <a:t>10/13/25</a:t>
             </a:fld>
             <a:endParaRPr lang="en-US"/>
           </a:p>
@@ -458,7 +458,7 @@
           <a:p>
             <a:fld id="{36763DCB-CE5A-6A42-9D77-F16639D72981}" type="datetimeFigureOut">
               <a:rPr lang="en-US" smtClean="0"/>
-              <a:t>5/1/25</a:t>
+              <a:t>10/13/25</a:t>
             </a:fld>
             <a:endParaRPr lang="en-US"/>
           </a:p>
@@ -666,7 +666,7 @@
           <a:p>
             <a:fld id="{36763DCB-CE5A-6A42-9D77-F16639D72981}" type="datetimeFigureOut">
               <a:rPr lang="en-US" smtClean="0"/>
-              <a:t>5/1/25</a:t>
+              <a:t>10/13/25</a:t>
             </a:fld>
             <a:endParaRPr lang="en-US"/>
           </a:p>
@@ -864,7 +864,7 @@
           <a:p>
             <a:fld id="{36763DCB-CE5A-6A42-9D77-F16639D72981}" type="datetimeFigureOut">
               <a:rPr lang="en-US" smtClean="0"/>
-              <a:t>5/1/25</a:t>
+              <a:t>10/13/25</a:t>
             </a:fld>
             <a:endParaRPr lang="en-US"/>
           </a:p>
@@ -1139,7 +1139,7 @@
           <a:p>
             <a:fld id="{36763DCB-CE5A-6A42-9D77-F16639D72981}" type="datetimeFigureOut">
               <a:rPr lang="en-US" smtClean="0"/>
-              <a:t>5/1/25</a:t>
+              <a:t>10/13/25</a:t>
             </a:fld>
             <a:endParaRPr lang="en-US"/>
           </a:p>
@@ -1404,7 +1404,7 @@
           <a:p>
             <a:fld id="{36763DCB-CE5A-6A42-9D77-F16639D72981}" type="datetimeFigureOut">
               <a:rPr lang="en-US" smtClean="0"/>
-              <a:t>5/1/25</a:t>
+              <a:t>10/13/25</a:t>
             </a:fld>
             <a:endParaRPr lang="en-US"/>
           </a:p>
@@ -1816,7 +1816,7 @@
           <a:p>
             <a:fld id="{36763DCB-CE5A-6A42-9D77-F16639D72981}" type="datetimeFigureOut">
               <a:rPr lang="en-US" smtClean="0"/>
-              <a:t>5/1/25</a:t>
+              <a:t>10/13/25</a:t>
             </a:fld>
             <a:endParaRPr lang="en-US"/>
           </a:p>
@@ -1957,7 +1957,7 @@
           <a:p>
             <a:fld id="{36763DCB-CE5A-6A42-9D77-F16639D72981}" type="datetimeFigureOut">
               <a:rPr lang="en-US" smtClean="0"/>
-              <a:t>5/1/25</a:t>
+              <a:t>10/13/25</a:t>
             </a:fld>
             <a:endParaRPr lang="en-US"/>
           </a:p>
@@ -2070,7 +2070,7 @@
           <a:p>
             <a:fld id="{36763DCB-CE5A-6A42-9D77-F16639D72981}" type="datetimeFigureOut">
               <a:rPr lang="en-US" smtClean="0"/>
-              <a:t>5/1/25</a:t>
+              <a:t>10/13/25</a:t>
             </a:fld>
             <a:endParaRPr lang="en-US"/>
           </a:p>
@@ -2381,7 +2381,7 @@
           <a:p>
             <a:fld id="{36763DCB-CE5A-6A42-9D77-F16639D72981}" type="datetimeFigureOut">
               <a:rPr lang="en-US" smtClean="0"/>
-              <a:t>5/1/25</a:t>
+              <a:t>10/13/25</a:t>
             </a:fld>
             <a:endParaRPr lang="en-US"/>
           </a:p>
@@ -2669,7 +2669,7 @@
           <a:p>
             <a:fld id="{36763DCB-CE5A-6A42-9D77-F16639D72981}" type="datetimeFigureOut">
               <a:rPr lang="en-US" smtClean="0"/>
-              <a:t>5/1/25</a:t>
+              <a:t>10/13/25</a:t>
             </a:fld>
             <a:endParaRPr lang="en-US"/>
           </a:p>
@@ -2910,7 +2910,7 @@
           <a:p>
             <a:fld id="{36763DCB-CE5A-6A42-9D77-F16639D72981}" type="datetimeFigureOut">
               <a:rPr lang="en-US" smtClean="0"/>
-              <a:t>5/1/25</a:t>
+              <a:t>10/13/25</a:t>
             </a:fld>
             <a:endParaRPr lang="en-US"/>
           </a:p>
@@ -3327,59 +3327,12 @@
           <a:chExt cx="0" cy="0"/>
         </a:xfrm>
       </p:grpSpPr>
-      <p:sp>
-        <p:nvSpPr>
-          <p:cNvPr id="6" name="TextBox 5">
-            <a:extLst>
-              <a:ext uri="{FF2B5EF4-FFF2-40B4-BE49-F238E27FC236}">
-                <a16:creationId xmlns:a16="http://schemas.microsoft.com/office/drawing/2014/main" id="{231B2C86-99BA-0FEA-2695-5530CAA96767}"/>
-              </a:ext>
-            </a:extLst>
-          </p:cNvPr>
-          <p:cNvSpPr txBox="1"/>
-          <p:nvPr/>
-        </p:nvSpPr>
-        <p:spPr>
-          <a:xfrm>
-            <a:off x="9182022" y="2653778"/>
-            <a:ext cx="1669047" cy="430887"/>
-          </a:xfrm>
-          <a:prstGeom prst="rect">
-            <a:avLst/>
-          </a:prstGeom>
-          <a:noFill/>
-        </p:spPr>
-        <p:txBody>
-          <a:bodyPr wrap="none" rtlCol="0">
-            <a:spAutoFit/>
-          </a:bodyPr>
-          <a:lstStyle/>
-          <a:p>
-            <a:r>
-              <a:rPr lang="en-US" sz="1100" dirty="0">
-                <a:latin typeface="Arial" panose="020B0604020202020204" pitchFamily="34" charset="0"/>
-                <a:cs typeface="Arial" panose="020B0604020202020204" pitchFamily="34" charset="0"/>
-              </a:rPr>
-              <a:t>True effect of exposure </a:t>
-            </a:r>
-          </a:p>
-          <a:p>
-            <a:r>
-              <a:rPr lang="en-US" sz="1100" dirty="0">
-                <a:latin typeface="Arial" panose="020B0604020202020204" pitchFamily="34" charset="0"/>
-                <a:cs typeface="Arial" panose="020B0604020202020204" pitchFamily="34" charset="0"/>
-              </a:rPr>
-              <a:t>on outcome (1.0)</a:t>
-            </a:r>
-          </a:p>
-        </p:txBody>
-      </p:sp>
       <p:pic>
         <p:nvPicPr>
-          <p:cNvPr id="16" name="Picture 15">
-            <a:extLst>
-              <a:ext uri="{FF2B5EF4-FFF2-40B4-BE49-F238E27FC236}">
-                <a16:creationId xmlns:a16="http://schemas.microsoft.com/office/drawing/2014/main" id="{F18EC30E-B73A-1835-63B8-12F186062F8A}"/>
+          <p:cNvPr id="4" name="Picture 3">
+            <a:extLst>
+              <a:ext uri="{FF2B5EF4-FFF2-40B4-BE49-F238E27FC236}">
+                <a16:creationId xmlns:a16="http://schemas.microsoft.com/office/drawing/2014/main" id="{9A4FCF9A-A0A7-08C5-75F0-41CF2BDCEE16}"/>
               </a:ext>
             </a:extLst>
           </p:cNvPr>
@@ -3396,14 +3349,82 @@
         </p:blipFill>
         <p:spPr>
           <a:xfrm>
-            <a:off x="0" y="601133"/>
-            <a:ext cx="11221024" cy="5205307"/>
+            <a:off x="210449" y="1041722"/>
+            <a:ext cx="11771101" cy="4573587"/>
           </a:xfrm>
           <a:prstGeom prst="rect">
             <a:avLst/>
           </a:prstGeom>
         </p:spPr>
       </p:pic>
+      <p:sp>
+        <p:nvSpPr>
+          <p:cNvPr id="6" name="TextBox 5">
+            <a:extLst>
+              <a:ext uri="{FF2B5EF4-FFF2-40B4-BE49-F238E27FC236}">
+                <a16:creationId xmlns:a16="http://schemas.microsoft.com/office/drawing/2014/main" id="{231B2C86-99BA-0FEA-2695-5530CAA96767}"/>
+              </a:ext>
+            </a:extLst>
+          </p:cNvPr>
+          <p:cNvSpPr txBox="1"/>
+          <p:nvPr/>
+        </p:nvSpPr>
+        <p:spPr>
+          <a:xfrm>
+            <a:off x="9841779" y="2838973"/>
+            <a:ext cx="1669047" cy="430887"/>
+          </a:xfrm>
+          <a:prstGeom prst="rect">
+            <a:avLst/>
+          </a:prstGeom>
+          <a:noFill/>
+        </p:spPr>
+        <p:txBody>
+          <a:bodyPr wrap="none" rtlCol="0">
+            <a:spAutoFit/>
+          </a:bodyPr>
+          <a:lstStyle/>
+          <a:p>
+            <a:r>
+              <a:rPr lang="en-US" sz="1100" dirty="0">
+                <a:latin typeface="Arial" panose="020B0604020202020204" pitchFamily="34" charset="0"/>
+                <a:cs typeface="Arial" panose="020B0604020202020204" pitchFamily="34" charset="0"/>
+              </a:rPr>
+              <a:t>True effect of exposure </a:t>
+            </a:r>
+          </a:p>
+          <a:p>
+            <a:r>
+              <a:rPr lang="en-US" sz="1100" dirty="0">
+                <a:latin typeface="Arial" panose="020B0604020202020204" pitchFamily="34" charset="0"/>
+                <a:cs typeface="Arial" panose="020B0604020202020204" pitchFamily="34" charset="0"/>
+              </a:rPr>
+              <a:t>on outcome (</a:t>
+            </a:r>
+            <a:r>
+              <a:rPr lang="el-GR" sz="1100" dirty="0">
+                <a:latin typeface="Arial" panose="020B0604020202020204" pitchFamily="34" charset="0"/>
+                <a:cs typeface="Arial" panose="020B0604020202020204" pitchFamily="34" charset="0"/>
+              </a:rPr>
+              <a:t>β</a:t>
+            </a:r>
+            <a:r>
+              <a:rPr lang="en-CA" sz="1100" dirty="0">
+                <a:latin typeface="Arial" panose="020B0604020202020204" pitchFamily="34" charset="0"/>
+                <a:cs typeface="Arial" panose="020B0604020202020204" pitchFamily="34" charset="0"/>
+              </a:rPr>
+              <a:t> =</a:t>
+            </a:r>
+            <a:r>
+              <a:rPr lang="en-US" sz="1100" dirty="0">
+                <a:latin typeface="Arial" panose="020B0604020202020204" pitchFamily="34" charset="0"/>
+                <a:cs typeface="Arial" panose="020B0604020202020204" pitchFamily="34" charset="0"/>
+              </a:rPr>
+              <a:t>1.0)</a:t>
+            </a:r>
+          </a:p>
+        </p:txBody>
+      </p:sp>
     </p:spTree>
     <p:extLst>
       <p:ext uri="{BB962C8B-B14F-4D97-AF65-F5344CB8AC3E}">
@@ -3449,14 +3470,14 @@
           <p:nvPr>
             <p:extLst>
               <p:ext uri="{D42A27DB-BD31-4B8C-83A1-F6EECF244321}">
-                <p14:modId xmlns:p14="http://schemas.microsoft.com/office/powerpoint/2010/main" val="1700961093"/>
+                <p14:modId xmlns:p14="http://schemas.microsoft.com/office/powerpoint/2010/main" val="1646688324"/>
               </p:ext>
             </p:extLst>
           </p:nvPr>
         </p:nvGraphicFramePr>
         <p:xfrm>
           <a:off x="982981" y="1719174"/>
-          <a:ext cx="9828000" cy="2295000"/>
+          <a:ext cx="10002293" cy="2455020"/>
         </p:xfrm>
         <a:graphic>
           <a:graphicData uri="http://schemas.openxmlformats.org/drawingml/2006/table">
@@ -3493,7 +3514,7 @@
                     </a:ext>
                   </a:extLst>
                 </a:gridCol>
-                <a:gridCol w="1404000">
+                <a:gridCol w="1578293">
                   <a:extLst>
                     <a:ext uri="{9D8B030D-6E8A-4147-A177-3AD203B41FA5}">
                       <a16:colId xmlns:a16="http://schemas.microsoft.com/office/drawing/2014/main" val="3768983624"/>
@@ -3720,7 +3741,7 @@
                           <a:latin typeface="Arial" panose="020B0604020202020204" pitchFamily="34" charset="0"/>
                           <a:cs typeface="Arial" panose="020B0604020202020204" pitchFamily="34" charset="0"/>
                         </a:rPr>
-                        <a:t>3. Modelling error</a:t>
+                        <a:t>3. Confounder Measurement Error</a:t>
                       </a:r>
                     </a:p>
                   </a:txBody>
@@ -3778,8 +3799,25 @@
                           <a:latin typeface="Arial" panose="020B0604020202020204" pitchFamily="34" charset="0"/>
                           <a:cs typeface="Arial" panose="020B0604020202020204" pitchFamily="34" charset="0"/>
                         </a:rPr>
-                        <a:t>4. Measurement error</a:t>
+                        <a:t>4. </a:t>
                       </a:r>
+                      <a:r>
+                        <a:rPr lang="en-US" sz="1050">
+                          <a:solidFill>
+                            <a:schemeClr val="tx1"/>
+                          </a:solidFill>
+                          <a:latin typeface="Arial" panose="020B0604020202020204" pitchFamily="34" charset="0"/>
+                          <a:cs typeface="Arial" panose="020B0604020202020204" pitchFamily="34" charset="0"/>
+                        </a:rPr>
+                        <a:t>Model misspecification</a:t>
+                      </a:r>
+                      <a:endParaRPr lang="en-US" sz="1050" dirty="0">
+                        <a:solidFill>
+                          <a:schemeClr val="tx1"/>
+                        </a:solidFill>
+                        <a:latin typeface="Arial" panose="020B0604020202020204" pitchFamily="34" charset="0"/>
+                        <a:cs typeface="Arial" panose="020B0604020202020204" pitchFamily="34" charset="0"/>
+                      </a:endParaRPr>
                     </a:p>
                   </a:txBody>
                   <a:tcPr>
@@ -4152,7 +4190,7 @@
                           <a:latin typeface="Arial" panose="020B0604020202020204" pitchFamily="34" charset="0"/>
                           <a:cs typeface="Arial" panose="020B0604020202020204" pitchFamily="34" charset="0"/>
                         </a:rPr>
-                        <a:t>1.25</a:t>
+                        <a:t>2.00</a:t>
                       </a:r>
                     </a:p>
                   </a:txBody>
@@ -4211,7 +4249,7 @@
                           <a:latin typeface="Arial" panose="020B0604020202020204" pitchFamily="34" charset="0"/>
                           <a:cs typeface="Arial" panose="020B0604020202020204" pitchFamily="34" charset="0"/>
                         </a:rPr>
-                        <a:t>2.00</a:t>
+                        <a:t>1.25</a:t>
                       </a:r>
                     </a:p>
                   </a:txBody>

</xml_diff>